<commit_message>
docs: refine Future Scope & Scalability Roadmap across README, QUICKSTART, and PPTX presentations
</commit_message>
<xml_diff>
--- a/MARUTHI_MSME_AI_Retail_Copilot_Detailed_Presentation.pptx
+++ b/MARUTHI_MSME_AI_Retail_Copilot_Detailed_Presentation.pptx
@@ -20,6 +20,7 @@
     <p:sldId id="268" r:id="rId19"/>
     <p:sldId id="269" r:id="rId20"/>
     <p:sldId id="270" r:id="rId21"/>
+    <p:sldId id="271" r:id="rId22"/>
   </p:sldIdLst>
   <p:sldSz cx="12191695" cy="6858000" type="screen4x3"/>
   <p:notesSz cx="6858000" cy="9144000"/>
@@ -4869,7 +4870,7 @@
               </a:defRPr>
             </a:pPr>
             <a:r>
-              <a:t>CONCLUSION &amp; LINK</a:t>
+              <a:t>PRODUCT ROADMAP &amp; FUTURE SCOPE</a:t>
             </a:r>
           </a:p>
         </p:txBody>
@@ -4904,7 +4905,7 @@
               </a:defRPr>
             </a:pPr>
             <a:r>
-              <a:t>MARUTHI — Ready for MSME Retail Deployment</a:t>
+              <a:t>TODAY → NEXT → SCALE → VISION Roadmap</a:t>
             </a:r>
           </a:p>
         </p:txBody>
@@ -4917,8 +4918,62 @@
         </p:nvSpPr>
         <p:spPr>
           <a:xfrm>
-            <a:off x="731520" y="1645920"/>
-            <a:ext cx="10698480" cy="4663440"/>
+            <a:off x="731520" y="1280160"/>
+            <a:ext cx="10698480" cy="411480"/>
+          </a:xfrm>
+          <a:prstGeom prst="roundRect">
+            <a:avLst/>
+          </a:prstGeom>
+          <a:solidFill>
+            <a:srgbClr val="1E3A8A"/>
+          </a:solidFill>
+          <a:ln>
+            <a:solidFill>
+              <a:srgbClr val="3B82F6"/>
+            </a:solidFill>
+          </a:ln>
+        </p:spPr>
+        <p:style>
+          <a:lnRef idx="1">
+            <a:schemeClr val="accent1"/>
+          </a:lnRef>
+          <a:fillRef idx="3">
+            <a:schemeClr val="accent1"/>
+          </a:fillRef>
+          <a:effectRef idx="2">
+            <a:schemeClr val="accent1"/>
+          </a:effectRef>
+          <a:fontRef idx="minor">
+            <a:schemeClr val="lt1"/>
+          </a:fontRef>
+        </p:style>
+        <p:txBody>
+          <a:bodyPr rtlCol="0" anchor="ctr" wrap="square"/>
+          <a:lstStyle/>
+          <a:p>
+            <a:pPr algn="ctr">
+              <a:defRPr sz="1100" b="1">
+                <a:solidFill>
+                  <a:srgbClr val="F8FAFC"/>
+                </a:solidFill>
+              </a:defRPr>
+            </a:pPr>
+            <a:r>
+              <a:t>ℹ️ Note: Features under NEXT, SCALE, and VISION represent future scope roadmap capabilities — not part of current hackathon MVP.</a:t>
+            </a:r>
+          </a:p>
+        </p:txBody>
+      </p:sp>
+      <p:sp>
+        <p:nvSpPr>
+          <p:cNvPr id="5" name="Rounded Rectangle 4"/>
+          <p:cNvSpPr/>
+          <p:nvPr/>
+        </p:nvSpPr>
+        <p:spPr>
+          <a:xfrm>
+            <a:off x="731520" y="1828800"/>
+            <a:ext cx="2560320" cy="4480560"/>
           </a:xfrm>
           <a:prstGeom prst="roundRect">
             <a:avLst/>
@@ -4951,6 +5006,422 @@
           <a:lstStyle/>
           <a:p>
             <a:pPr algn="ctr">
+              <a:defRPr sz="1400" b="1">
+                <a:solidFill>
+                  <a:srgbClr val="10B981"/>
+                </a:solidFill>
+              </a:defRPr>
+            </a:pPr>
+            <a:r>
+              <a:t>1. TODAY — WORKING MVP</a:t>
+            </a:r>
+          </a:p>
+          <a:p>
+            <a:pPr>
+              <a:defRPr sz="1100">
+                <a:solidFill>
+                  <a:srgbClr val="94A3B8"/>
+                </a:solidFill>
+              </a:defRPr>
+            </a:pPr>
+            <a:r>
+              <a:t>• Natural Voice &amp; Text Sales Capture</a:t>
+            </a:r>
+            <a:br/>
+            <a:r>
+              <a:t>• AI Wholesale Invoice OCR &amp; Match</a:t>
+            </a:r>
+            <a:br/>
+            <a:r>
+              <a:t>• Pure Deterministic Financial Engine</a:t>
+            </a:r>
+            <a:br/>
+            <a:r>
+              <a:t>• Real-Time BI &amp; Demand Forecasting</a:t>
+            </a:r>
+            <a:br/>
+            <a:r>
+              <a:t>• Grounded AI Advisor &amp; Local Intel</a:t>
+            </a:r>
+            <a:br/>
+            <a:r>
+              <a:t>• PDF / 7-Sheet XLSX / PNG Reports</a:t>
+            </a:r>
+            <a:br/>
+            <a:r>
+              <a:t>• 83/83 Pytests Passing</a:t>
+            </a:r>
+          </a:p>
+        </p:txBody>
+      </p:sp>
+      <p:sp>
+        <p:nvSpPr>
+          <p:cNvPr id="6" name="Rounded Rectangle 5"/>
+          <p:cNvSpPr/>
+          <p:nvPr/>
+        </p:nvSpPr>
+        <p:spPr>
+          <a:xfrm>
+            <a:off x="3429000" y="1828800"/>
+            <a:ext cx="2560320" cy="4480560"/>
+          </a:xfrm>
+          <a:prstGeom prst="roundRect">
+            <a:avLst/>
+          </a:prstGeom>
+          <a:solidFill>
+            <a:srgbClr val="1E293B"/>
+          </a:solidFill>
+          <a:ln>
+            <a:solidFill>
+              <a:srgbClr val="334155"/>
+            </a:solidFill>
+          </a:ln>
+        </p:spPr>
+        <p:style>
+          <a:lnRef idx="1">
+            <a:schemeClr val="accent1"/>
+          </a:lnRef>
+          <a:fillRef idx="3">
+            <a:schemeClr val="accent1"/>
+          </a:fillRef>
+          <a:effectRef idx="2">
+            <a:schemeClr val="accent1"/>
+          </a:effectRef>
+          <a:fontRef idx="minor">
+            <a:schemeClr val="lt1"/>
+          </a:fontRef>
+        </p:style>
+        <p:txBody>
+          <a:bodyPr rtlCol="0" anchor="ctr" wrap="square"/>
+          <a:lstStyle/>
+          <a:p>
+            <a:pPr algn="ctr">
+              <a:defRPr sz="1400" b="1">
+                <a:solidFill>
+                  <a:srgbClr val="3B82F6"/>
+                </a:solidFill>
+              </a:defRPr>
+            </a:pPr>
+            <a:r>
+              <a:t>2. NEXT — PRODUCT SCALE</a:t>
+            </a:r>
+          </a:p>
+          <a:p>
+            <a:pPr>
+              <a:defRPr sz="1100">
+                <a:solidFill>
+                  <a:srgbClr val="94A3B8"/>
+                </a:solidFill>
+              </a:defRPr>
+            </a:pPr>
+            <a:r>
+              <a:t>• Production PostgreSQL/Supabase DB</a:t>
+            </a:r>
+            <a:br/>
+            <a:r>
+              <a:t>• Multi-Shop Architecture &amp; RBAC Auth</a:t>
+            </a:r>
+            <a:br/>
+            <a:r>
+              <a:t>• Multilingual Support (Hindi, Telugu, etc.)</a:t>
+            </a:r>
+            <a:br/>
+            <a:r>
+              <a:t>• Offline-First PWA Sync (IndexedDB)</a:t>
+            </a:r>
+            <a:br/>
+            <a:r>
+              <a:t>• Dynamic Multi-LLM Provider Routing</a:t>
+            </a:r>
+          </a:p>
+        </p:txBody>
+      </p:sp>
+      <p:sp>
+        <p:nvSpPr>
+          <p:cNvPr id="7" name="Rounded Rectangle 6"/>
+          <p:cNvSpPr/>
+          <p:nvPr/>
+        </p:nvSpPr>
+        <p:spPr>
+          <a:xfrm>
+            <a:off x="6126480" y="1828800"/>
+            <a:ext cx="2560320" cy="4480560"/>
+          </a:xfrm>
+          <a:prstGeom prst="roundRect">
+            <a:avLst/>
+          </a:prstGeom>
+          <a:solidFill>
+            <a:srgbClr val="1E293B"/>
+          </a:solidFill>
+          <a:ln>
+            <a:solidFill>
+              <a:srgbClr val="334155"/>
+            </a:solidFill>
+          </a:ln>
+        </p:spPr>
+        <p:style>
+          <a:lnRef idx="1">
+            <a:schemeClr val="accent1"/>
+          </a:lnRef>
+          <a:fillRef idx="3">
+            <a:schemeClr val="accent1"/>
+          </a:fillRef>
+          <a:effectRef idx="2">
+            <a:schemeClr val="accent1"/>
+          </a:effectRef>
+          <a:fontRef idx="minor">
+            <a:schemeClr val="lt1"/>
+          </a:fontRef>
+        </p:style>
+        <p:txBody>
+          <a:bodyPr rtlCol="0" anchor="ctr" wrap="square"/>
+          <a:lstStyle/>
+          <a:p>
+            <a:pPr algn="ctr">
+              <a:defRPr sz="1400" b="1">
+                <a:solidFill>
+                  <a:srgbClr val="F59E0B"/>
+                </a:solidFill>
+              </a:defRPr>
+            </a:pPr>
+            <a:r>
+              <a:t>3. SCALE — ECOSYSTEM</a:t>
+            </a:r>
+          </a:p>
+          <a:p>
+            <a:pPr>
+              <a:defRPr sz="1100">
+                <a:solidFill>
+                  <a:srgbClr val="94A3B8"/>
+                </a:solidFill>
+              </a:defRPr>
+            </a:pPr>
+            <a:r>
+              <a:t>• Supplier &amp; B2B Wholesale Integration</a:t>
+            </a:r>
+            <a:br/>
+            <a:r>
+              <a:t>• Automated Reorder PO Workflows</a:t>
+            </a:r>
+            <a:br/>
+            <a:r>
+              <a:t>• WhatsApp Business &amp; Voice Bot</a:t>
+            </a:r>
+            <a:br/>
+            <a:r>
+              <a:t>• POS, Payment Gateway &amp; Tally Sync</a:t>
+            </a:r>
+          </a:p>
+        </p:txBody>
+      </p:sp>
+      <p:sp>
+        <p:nvSpPr>
+          <p:cNvPr id="8" name="Rounded Rectangle 7"/>
+          <p:cNvSpPr/>
+          <p:nvPr/>
+        </p:nvSpPr>
+        <p:spPr>
+          <a:xfrm>
+            <a:off x="8823960" y="1828800"/>
+            <a:ext cx="2560320" cy="4480560"/>
+          </a:xfrm>
+          <a:prstGeom prst="roundRect">
+            <a:avLst/>
+          </a:prstGeom>
+          <a:solidFill>
+            <a:srgbClr val="1E293B"/>
+          </a:solidFill>
+          <a:ln>
+            <a:solidFill>
+              <a:srgbClr val="334155"/>
+            </a:solidFill>
+          </a:ln>
+        </p:spPr>
+        <p:style>
+          <a:lnRef idx="1">
+            <a:schemeClr val="accent1"/>
+          </a:lnRef>
+          <a:fillRef idx="3">
+            <a:schemeClr val="accent1"/>
+          </a:fillRef>
+          <a:effectRef idx="2">
+            <a:schemeClr val="accent1"/>
+          </a:effectRef>
+          <a:fontRef idx="minor">
+            <a:schemeClr val="lt1"/>
+          </a:fontRef>
+        </p:style>
+        <p:txBody>
+          <a:bodyPr rtlCol="0" anchor="ctr" wrap="square"/>
+          <a:lstStyle/>
+          <a:p>
+            <a:pPr algn="ctr">
+              <a:defRPr sz="1400" b="1">
+                <a:solidFill>
+                  <a:srgbClr val="A855F7"/>
+                </a:solidFill>
+              </a:defRPr>
+            </a:pPr>
+            <a:r>
+              <a:t>4. VISION — RETAIL AI OS</a:t>
+            </a:r>
+          </a:p>
+          <a:p>
+            <a:pPr>
+              <a:defRPr sz="1100">
+                <a:solidFill>
+                  <a:srgbClr val="94A3B8"/>
+                </a:solidFill>
+              </a:defRPr>
+            </a:pPr>
+            <a:r>
+              <a:t>"An AI Operating System for Small Retailers"</a:t>
+            </a:r>
+            <a:br/>
+            <a:r>
+              <a:t>Natural voice, text, mobile &amp; WhatsApp interface for complete sales, inventory, demand forecasting &amp; automated supplier fulfillment.</a:t>
+            </a:r>
+          </a:p>
+        </p:txBody>
+      </p:sp>
+    </p:spTree>
+  </p:cSld>
+  <p:clrMapOvr>
+    <a:masterClrMapping/>
+  </p:clrMapOvr>
+</p:sld>
+</file>
+
+<file path=ppt/slides/slide16.xml><?xml version="1.0" encoding="utf-8"?>
+<p:sld xmlns:a="http://schemas.openxmlformats.org/drawingml/2006/main" xmlns:p="http://schemas.openxmlformats.org/presentationml/2006/main" xmlns:r="http://schemas.openxmlformats.org/officeDocument/2006/relationships">
+  <p:cSld>
+    <p:bg>
+      <p:bgPr>
+        <a:solidFill>
+          <a:srgbClr val="0F172A"/>
+        </a:solidFill>
+        <a:effectLst/>
+      </p:bgPr>
+    </p:bg>
+    <p:spTree>
+      <p:nvGrpSpPr>
+        <p:cNvPr id="1" name=""/>
+        <p:cNvGrpSpPr/>
+        <p:nvPr/>
+      </p:nvGrpSpPr>
+      <p:grpSpPr/>
+      <p:sp>
+        <p:nvSpPr>
+          <p:cNvPr id="2" name="TextBox 1"/>
+          <p:cNvSpPr txBox="1"/>
+          <p:nvPr/>
+        </p:nvSpPr>
+        <p:spPr>
+          <a:xfrm>
+            <a:off x="731520" y="365760"/>
+            <a:ext cx="10698480" cy="365760"/>
+          </a:xfrm>
+          <a:prstGeom prst="rect">
+            <a:avLst/>
+          </a:prstGeom>
+          <a:noFill/>
+        </p:spPr>
+        <p:txBody>
+          <a:bodyPr wrap="square">
+            <a:spAutoFit/>
+          </a:bodyPr>
+          <a:lstStyle/>
+          <a:p>
+            <a:pPr>
+              <a:defRPr sz="1100" b="1">
+                <a:solidFill>
+                  <a:srgbClr val="3B82F6"/>
+                </a:solidFill>
+              </a:defRPr>
+            </a:pPr>
+            <a:r>
+              <a:t>CONCLUSION &amp; LINK</a:t>
+            </a:r>
+          </a:p>
+        </p:txBody>
+      </p:sp>
+      <p:sp>
+        <p:nvSpPr>
+          <p:cNvPr id="3" name="TextBox 2"/>
+          <p:cNvSpPr txBox="1"/>
+          <p:nvPr/>
+        </p:nvSpPr>
+        <p:spPr>
+          <a:xfrm>
+            <a:off x="731520" y="685800"/>
+            <a:ext cx="10698480" cy="731520"/>
+          </a:xfrm>
+          <a:prstGeom prst="rect">
+            <a:avLst/>
+          </a:prstGeom>
+          <a:noFill/>
+        </p:spPr>
+        <p:txBody>
+          <a:bodyPr wrap="square">
+            <a:spAutoFit/>
+          </a:bodyPr>
+          <a:lstStyle/>
+          <a:p>
+            <a:pPr>
+              <a:defRPr sz="2400" b="1">
+                <a:solidFill>
+                  <a:srgbClr val="F8FAFC"/>
+                </a:solidFill>
+              </a:defRPr>
+            </a:pPr>
+            <a:r>
+              <a:t>MARUTHI — Ready for MSME Retail Deployment</a:t>
+            </a:r>
+          </a:p>
+        </p:txBody>
+      </p:sp>
+      <p:sp>
+        <p:nvSpPr>
+          <p:cNvPr id="4" name="Rounded Rectangle 3"/>
+          <p:cNvSpPr/>
+          <p:nvPr/>
+        </p:nvSpPr>
+        <p:spPr>
+          <a:xfrm>
+            <a:off x="731520" y="1645920"/>
+            <a:ext cx="10698480" cy="4663440"/>
+          </a:xfrm>
+          <a:prstGeom prst="roundRect">
+            <a:avLst/>
+          </a:prstGeom>
+          <a:solidFill>
+            <a:srgbClr val="1E293B"/>
+          </a:solidFill>
+          <a:ln>
+            <a:solidFill>
+              <a:srgbClr val="334155"/>
+            </a:solidFill>
+          </a:ln>
+        </p:spPr>
+        <p:style>
+          <a:lnRef idx="1">
+            <a:schemeClr val="accent1"/>
+          </a:lnRef>
+          <a:fillRef idx="3">
+            <a:schemeClr val="accent1"/>
+          </a:fillRef>
+          <a:effectRef idx="2">
+            <a:schemeClr val="accent1"/>
+          </a:effectRef>
+          <a:fontRef idx="minor">
+            <a:schemeClr val="lt1"/>
+          </a:fontRef>
+        </p:style>
+        <p:txBody>
+          <a:bodyPr rtlCol="0" anchor="ctr" wrap="square"/>
+          <a:lstStyle/>
+          <a:p>
+            <a:pPr algn="ctr">
               <a:defRPr sz="2000" b="1">
                 <a:solidFill>
                   <a:srgbClr val="10B981"/>
@@ -5006,7 +5477,7 @@
               </a:defRPr>
             </a:pPr>
             <a:r>
-              <a:t>• ✅ Complete Documentation: README.md, QUICKSTART.md &amp; 15-Slide Presentation included.</a:t>
+              <a:t>• ✅ Complete Documentation: README.md, QUICKSTART.md &amp; Presentation included.</a:t>
             </a:r>
           </a:p>
           <a:p>

</xml_diff>